<commit_message>
Update presentation and README
</commit_message>
<xml_diff>
--- a/Access Control System Presentation.pptx
+++ b/Access Control System Presentation.pptx
@@ -313,7 +313,7 @@
           <a:p>
             <a:fld id="{5BCAD085-E8A6-8845-BD4E-CB4CCA059FC4}" type="datetimeFigureOut">
               <a:rPr lang="en-US" smtClean="0"/>
-              <a:t>9/28/26</a:t>
+              <a:t>9/29/26</a:t>
             </a:fld>
             <a:endParaRPr lang="en-US"/>
           </a:p>
@@ -481,7 +481,7 @@
           <a:p>
             <a:fld id="{5BCAD085-E8A6-8845-BD4E-CB4CCA059FC4}" type="datetimeFigureOut">
               <a:rPr lang="en-US" smtClean="0"/>
-              <a:t>9/28/26</a:t>
+              <a:t>9/29/26</a:t>
             </a:fld>
             <a:endParaRPr lang="en-US"/>
           </a:p>
@@ -659,7 +659,7 @@
           <a:p>
             <a:fld id="{5BCAD085-E8A6-8845-BD4E-CB4CCA059FC4}" type="datetimeFigureOut">
               <a:rPr lang="en-US" smtClean="0"/>
-              <a:t>9/28/26</a:t>
+              <a:t>9/29/26</a:t>
             </a:fld>
             <a:endParaRPr lang="en-US"/>
           </a:p>
@@ -827,7 +827,7 @@
           <a:p>
             <a:fld id="{5BCAD085-E8A6-8845-BD4E-CB4CCA059FC4}" type="datetimeFigureOut">
               <a:rPr lang="en-US" smtClean="0"/>
-              <a:t>9/28/26</a:t>
+              <a:t>9/29/26</a:t>
             </a:fld>
             <a:endParaRPr lang="en-US"/>
           </a:p>
@@ -1072,7 +1072,7 @@
           <a:p>
             <a:fld id="{5BCAD085-E8A6-8845-BD4E-CB4CCA059FC4}" type="datetimeFigureOut">
               <a:rPr lang="en-US" smtClean="0"/>
-              <a:t>9/28/26</a:t>
+              <a:t>9/29/26</a:t>
             </a:fld>
             <a:endParaRPr lang="en-US"/>
           </a:p>
@@ -1357,7 +1357,7 @@
           <a:p>
             <a:fld id="{5BCAD085-E8A6-8845-BD4E-CB4CCA059FC4}" type="datetimeFigureOut">
               <a:rPr lang="en-US" smtClean="0"/>
-              <a:t>9/28/26</a:t>
+              <a:t>9/29/26</a:t>
             </a:fld>
             <a:endParaRPr lang="en-US"/>
           </a:p>
@@ -1776,7 +1776,7 @@
           <a:p>
             <a:fld id="{5BCAD085-E8A6-8845-BD4E-CB4CCA059FC4}" type="datetimeFigureOut">
               <a:rPr lang="en-US" smtClean="0"/>
-              <a:t>9/28/26</a:t>
+              <a:t>9/29/26</a:t>
             </a:fld>
             <a:endParaRPr lang="en-US"/>
           </a:p>
@@ -1893,7 +1893,7 @@
           <a:p>
             <a:fld id="{5BCAD085-E8A6-8845-BD4E-CB4CCA059FC4}" type="datetimeFigureOut">
               <a:rPr lang="en-US" smtClean="0"/>
-              <a:t>9/28/26</a:t>
+              <a:t>9/29/26</a:t>
             </a:fld>
             <a:endParaRPr lang="en-US"/>
           </a:p>
@@ -1988,7 +1988,7 @@
           <a:p>
             <a:fld id="{5BCAD085-E8A6-8845-BD4E-CB4CCA059FC4}" type="datetimeFigureOut">
               <a:rPr lang="en-US" smtClean="0"/>
-              <a:t>9/28/26</a:t>
+              <a:t>9/29/26</a:t>
             </a:fld>
             <a:endParaRPr lang="en-US"/>
           </a:p>
@@ -2263,7 +2263,7 @@
           <a:p>
             <a:fld id="{5BCAD085-E8A6-8845-BD4E-CB4CCA059FC4}" type="datetimeFigureOut">
               <a:rPr lang="en-US" smtClean="0"/>
-              <a:t>9/28/26</a:t>
+              <a:t>9/29/26</a:t>
             </a:fld>
             <a:endParaRPr lang="en-US"/>
           </a:p>
@@ -2515,7 +2515,7 @@
           <a:p>
             <a:fld id="{5BCAD085-E8A6-8845-BD4E-CB4CCA059FC4}" type="datetimeFigureOut">
               <a:rPr lang="en-US" smtClean="0"/>
-              <a:t>9/28/26</a:t>
+              <a:t>9/29/26</a:t>
             </a:fld>
             <a:endParaRPr lang="en-US"/>
           </a:p>
@@ -2726,7 +2726,7 @@
           <a:p>
             <a:fld id="{5BCAD085-E8A6-8845-BD4E-CB4CCA059FC4}" type="datetimeFigureOut">
               <a:rPr lang="en-US" smtClean="0"/>
-              <a:t>9/28/26</a:t>
+              <a:t>9/29/26</a:t>
             </a:fld>
             <a:endParaRPr lang="en-US"/>
           </a:p>
@@ -3270,7 +3270,23 @@
             </a:r>
             <a:r>
               <a:rPr dirty="0"/>
-              <a:t> RFID/NFC</a:t>
+              <a:t> RFID</a:t>
+            </a:r>
+            <a:r>
+              <a:rPr lang="ru-RU" dirty="0"/>
+              <a:t> </a:t>
+            </a:r>
+            <a:r>
+              <a:rPr dirty="0"/>
+              <a:t>/</a:t>
+            </a:r>
+            <a:r>
+              <a:rPr lang="ru-RU" dirty="0"/>
+              <a:t> </a:t>
+            </a:r>
+            <a:r>
+              <a:rPr dirty="0"/>
+              <a:t>NFC</a:t>
             </a:r>
           </a:p>
         </p:txBody>
@@ -3306,10 +3322,6 @@
               </a:defRPr>
             </a:pPr>
             <a:r>
-              <a:rPr lang="ru-RU" dirty="0"/>
-              <a:t>Куликов Н.Н. / </a:t>
-            </a:r>
-            <a:r>
               <a:rPr dirty="0" err="1"/>
               <a:t>Программа</a:t>
             </a:r>
@@ -3341,6 +3353,94 @@
               <a:rPr dirty="0"/>
               <a:t> 2026</a:t>
             </a:r>
+          </a:p>
+        </p:txBody>
+      </p:sp>
+      <p:sp>
+        <p:nvSpPr>
+          <p:cNvPr id="7" name="TextBox 6">
+            <a:extLst>
+              <a:ext uri="{FF2B5EF4-FFF2-40B4-BE49-F238E27FC236}">
+                <a16:creationId xmlns:a16="http://schemas.microsoft.com/office/drawing/2014/main" id="{C031145C-2A35-F359-8AC6-BF0927977BE8}"/>
+              </a:ext>
+            </a:extLst>
+          </p:cNvPr>
+          <p:cNvSpPr txBox="1"/>
+          <p:nvPr/>
+        </p:nvSpPr>
+        <p:spPr>
+          <a:xfrm>
+            <a:off x="731520" y="6007388"/>
+            <a:ext cx="10058400" cy="292388"/>
+          </a:xfrm>
+          <a:prstGeom prst="rect">
+            <a:avLst/>
+          </a:prstGeom>
+          <a:noFill/>
+        </p:spPr>
+        <p:txBody>
+          <a:bodyPr wrap="square">
+            <a:spAutoFit/>
+          </a:bodyPr>
+          <a:lstStyle/>
+          <a:p>
+            <a:pPr>
+              <a:defRPr sz="1300" b="0">
+                <a:solidFill>
+                  <a:srgbClr val="5A697D"/>
+                </a:solidFill>
+                <a:latin typeface="Arial"/>
+              </a:defRPr>
+            </a:pPr>
+            <a:r>
+              <a:rPr lang="ru-RU" dirty="0"/>
+              <a:t>Автор: Куликов Николай Николаевич</a:t>
+            </a:r>
+            <a:endParaRPr dirty="0"/>
+          </a:p>
+        </p:txBody>
+      </p:sp>
+      <p:sp>
+        <p:nvSpPr>
+          <p:cNvPr id="9" name="TextBox 8">
+            <a:extLst>
+              <a:ext uri="{FF2B5EF4-FFF2-40B4-BE49-F238E27FC236}">
+                <a16:creationId xmlns:a16="http://schemas.microsoft.com/office/drawing/2014/main" id="{2EAA935D-F9BF-848E-BFFF-A042DB131243}"/>
+              </a:ext>
+            </a:extLst>
+          </p:cNvPr>
+          <p:cNvSpPr txBox="1"/>
+          <p:nvPr/>
+        </p:nvSpPr>
+        <p:spPr>
+          <a:xfrm>
+            <a:off x="731520" y="6299776"/>
+            <a:ext cx="10058400" cy="292388"/>
+          </a:xfrm>
+          <a:prstGeom prst="rect">
+            <a:avLst/>
+          </a:prstGeom>
+          <a:noFill/>
+        </p:spPr>
+        <p:txBody>
+          <a:bodyPr wrap="square">
+            <a:spAutoFit/>
+          </a:bodyPr>
+          <a:lstStyle/>
+          <a:p>
+            <a:pPr>
+              <a:defRPr sz="1300" b="0">
+                <a:solidFill>
+                  <a:srgbClr val="5A697D"/>
+                </a:solidFill>
+                <a:latin typeface="Arial"/>
+              </a:defRPr>
+            </a:pPr>
+            <a:r>
+              <a:rPr lang="ru-RU" dirty="0"/>
+              <a:t>Руководитель: Кузьмин Константин Михайлович</a:t>
+            </a:r>
+            <a:endParaRPr dirty="0"/>
           </a:p>
         </p:txBody>
       </p:sp>
@@ -8226,7 +8326,7 @@
         </p:nvSpPr>
         <p:spPr>
           <a:xfrm>
-            <a:off x="4788671" y="411480"/>
+            <a:off x="4788670" y="242203"/>
             <a:ext cx="2401298" cy="507831"/>
           </a:xfrm>
           <a:prstGeom prst="rect">
@@ -8299,9 +8399,125 @@
           </a:p>
         </p:txBody>
       </p:sp>
+      <p:sp>
+        <p:nvSpPr>
+          <p:cNvPr id="5" name="TextBox 4"/>
+          <p:cNvSpPr txBox="1"/>
+          <p:nvPr/>
+        </p:nvSpPr>
+        <p:spPr>
+          <a:xfrm>
+            <a:off x="838200" y="6369744"/>
+            <a:ext cx="10515600" cy="338554"/>
+          </a:xfrm>
+          <a:prstGeom prst="rect">
+            <a:avLst/>
+          </a:prstGeom>
+          <a:noFill/>
+        </p:spPr>
+        <p:txBody>
+          <a:bodyPr wrap="square">
+            <a:spAutoFit/>
+          </a:bodyPr>
+          <a:lstStyle/>
+          <a:p>
+            <a:pPr algn="ctr">
+              <a:defRPr sz="1600" b="1">
+                <a:solidFill>
+                  <a:srgbClr val="172033"/>
+                </a:solidFill>
+                <a:latin typeface="Arial"/>
+              </a:defRPr>
+            </a:pPr>
+            <a:r>
+              <a:rPr dirty="0"/>
+              <a:t>PK/FK </a:t>
+            </a:r>
+            <a:r>
+              <a:rPr lang="ru-RU" dirty="0"/>
+              <a:t>/</a:t>
+            </a:r>
+            <a:r>
+              <a:rPr dirty="0"/>
+              <a:t> UNIQUE UID </a:t>
+            </a:r>
+            <a:r>
+              <a:rPr lang="ru-RU" dirty="0"/>
+              <a:t>/</a:t>
+            </a:r>
+            <a:r>
+              <a:rPr dirty="0"/>
+              <a:t> </a:t>
+            </a:r>
+            <a:r>
+              <a:rPr lang="ru-RU" dirty="0"/>
+              <a:t>Проверка</a:t>
+            </a:r>
+            <a:r>
+              <a:rPr dirty="0"/>
+              <a:t> </a:t>
+            </a:r>
+            <a:r>
+              <a:rPr dirty="0" err="1"/>
+              <a:t>статусов</a:t>
+            </a:r>
+            <a:r>
+              <a:rPr dirty="0"/>
+              <a:t> </a:t>
+            </a:r>
+            <a:r>
+              <a:rPr lang="ru-RU" dirty="0"/>
+              <a:t>/</a:t>
+            </a:r>
+            <a:r>
+              <a:rPr dirty="0"/>
+              <a:t> </a:t>
+            </a:r>
+            <a:r>
+              <a:rPr lang="ru-RU" dirty="0"/>
+              <a:t>М</a:t>
+            </a:r>
+            <a:r>
+              <a:rPr dirty="0" err="1"/>
+              <a:t>играции</a:t>
+            </a:r>
+            <a:r>
+              <a:rPr dirty="0"/>
+              <a:t> </a:t>
+            </a:r>
+            <a:r>
+              <a:rPr dirty="0" err="1"/>
+              <a:t>без</a:t>
+            </a:r>
+            <a:r>
+              <a:rPr dirty="0"/>
+              <a:t> </a:t>
+            </a:r>
+            <a:r>
+              <a:rPr dirty="0" err="1"/>
+              <a:t>удаления</a:t>
+            </a:r>
+            <a:r>
+              <a:rPr dirty="0"/>
+              <a:t> </a:t>
+            </a:r>
+            <a:r>
+              <a:rPr dirty="0" err="1"/>
+              <a:t>данных</a:t>
+            </a:r>
+            <a:endParaRPr dirty="0"/>
+          </a:p>
+        </p:txBody>
+      </p:sp>
       <p:pic>
         <p:nvPicPr>
-          <p:cNvPr id="4" name="Picture 3" descr="erd.png"/>
+          <p:cNvPr id="7" name="Рисунок 6">
+            <a:extLst>
+              <a:ext uri="{FF2B5EF4-FFF2-40B4-BE49-F238E27FC236}">
+                <a16:creationId xmlns:a16="http://schemas.microsoft.com/office/drawing/2014/main" id="{8ADF768A-ADE9-43C6-AC51-EA9FD8CAC84D}"/>
+              </a:ext>
+            </a:extLst>
+          </p:cNvPr>
           <p:cNvPicPr>
             <a:picLocks noChangeAspect="1"/>
           </p:cNvPicPr>
@@ -8315,124 +8531,14 @@
         </p:blipFill>
         <p:spPr>
           <a:xfrm>
-            <a:off x="21021" y="1914181"/>
-            <a:ext cx="12149958" cy="2073926"/>
+            <a:off x="2012405" y="919311"/>
+            <a:ext cx="7953829" cy="5395203"/>
           </a:xfrm>
           <a:prstGeom prst="rect">
             <a:avLst/>
           </a:prstGeom>
         </p:spPr>
       </p:pic>
-      <p:sp>
-        <p:nvSpPr>
-          <p:cNvPr id="5" name="TextBox 4"/>
-          <p:cNvSpPr txBox="1"/>
-          <p:nvPr/>
-        </p:nvSpPr>
-        <p:spPr>
-          <a:xfrm>
-            <a:off x="731520" y="5715000"/>
-            <a:ext cx="10515600" cy="338554"/>
-          </a:xfrm>
-          <a:prstGeom prst="rect">
-            <a:avLst/>
-          </a:prstGeom>
-          <a:noFill/>
-        </p:spPr>
-        <p:txBody>
-          <a:bodyPr wrap="square">
-            <a:spAutoFit/>
-          </a:bodyPr>
-          <a:lstStyle/>
-          <a:p>
-            <a:pPr algn="ctr">
-              <a:defRPr sz="1600" b="1">
-                <a:solidFill>
-                  <a:srgbClr val="172033"/>
-                </a:solidFill>
-                <a:latin typeface="Arial"/>
-              </a:defRPr>
-            </a:pPr>
-            <a:r>
-              <a:rPr dirty="0"/>
-              <a:t>PK/FK </a:t>
-            </a:r>
-            <a:r>
-              <a:rPr lang="ru-RU" dirty="0"/>
-              <a:t>/</a:t>
-            </a:r>
-            <a:r>
-              <a:rPr dirty="0"/>
-              <a:t> UNIQUE UID </a:t>
-            </a:r>
-            <a:r>
-              <a:rPr lang="ru-RU" dirty="0"/>
-              <a:t>/</a:t>
-            </a:r>
-            <a:r>
-              <a:rPr dirty="0"/>
-              <a:t> </a:t>
-            </a:r>
-            <a:r>
-              <a:rPr lang="ru-RU" dirty="0"/>
-              <a:t>Проверка</a:t>
-            </a:r>
-            <a:r>
-              <a:rPr dirty="0"/>
-              <a:t> </a:t>
-            </a:r>
-            <a:r>
-              <a:rPr dirty="0" err="1"/>
-              <a:t>статусов</a:t>
-            </a:r>
-            <a:r>
-              <a:rPr dirty="0"/>
-              <a:t> </a:t>
-            </a:r>
-            <a:r>
-              <a:rPr lang="ru-RU" dirty="0"/>
-              <a:t>/</a:t>
-            </a:r>
-            <a:r>
-              <a:rPr dirty="0"/>
-              <a:t> </a:t>
-            </a:r>
-            <a:r>
-              <a:rPr lang="ru-RU" dirty="0"/>
-              <a:t>М</a:t>
-            </a:r>
-            <a:r>
-              <a:rPr dirty="0" err="1"/>
-              <a:t>играции</a:t>
-            </a:r>
-            <a:r>
-              <a:rPr dirty="0"/>
-              <a:t> </a:t>
-            </a:r>
-            <a:r>
-              <a:rPr dirty="0" err="1"/>
-              <a:t>без</a:t>
-            </a:r>
-            <a:r>
-              <a:rPr dirty="0"/>
-              <a:t> </a:t>
-            </a:r>
-            <a:r>
-              <a:rPr dirty="0" err="1"/>
-              <a:t>удаления</a:t>
-            </a:r>
-            <a:r>
-              <a:rPr dirty="0"/>
-              <a:t> </a:t>
-            </a:r>
-            <a:r>
-              <a:rPr dirty="0" err="1"/>
-              <a:t>данных</a:t>
-            </a:r>
-            <a:endParaRPr dirty="0"/>
-          </a:p>
-        </p:txBody>
-      </p:sp>
     </p:spTree>
   </p:cSld>
   <p:clrMapOvr>

</xml_diff>